<commit_message>
docs: state the full safety-gate flow and pitch line in judge-ready deck
Architecture slide now shows VoBiz -> Sarvam -> Claude -> safety gate
-> Dodo / confirm / Freshworks -> ElevenLabs. Adds the owner, the key
pitch sentence, per-tool prevention roles, and names Claude in the
decision and agentic slides.

Co-Authored-By: Claude Opus 5.5 <noreply@anthropic.com>
Claude-Session: https://claude.ai/code/session_012DT45KpxUQbVV43mbMd9KB
</commit_message>
<xml_diff>
--- a/docs/presentation/CodemixSkill-Judge-Ready.pptx
+++ b/docs/presentation/CodemixSkill-Judge-Ready.pptx
@@ -3383,6 +3383,45 @@
         </p:nvSpPr>
         <p:spPr>
           <a:xfrm>
+            <a:off x="731520" y="5074920"/>
+            <a:ext cx="10789920" cy="457200"/>
+          </a:xfrm>
+          <a:prstGeom prst="rect">
+            <a:avLst/>
+          </a:prstGeom>
+          <a:noFill/>
+          <a:ln/>
+        </p:spPr>
+        <p:txBody>
+          <a:bodyPr wrap="square" lIns="0" tIns="0" rIns="0" bIns="0" rtlCol="0" anchor="t"/>
+          <a:lstStyle/>
+          <a:p>
+            <a:pPr indent="0" marL="0">
+              <a:buNone/>
+            </a:pPr>
+            <a:r>
+              <a:rPr lang="en-US" sz="1600" b="1" dirty="0">
+                <a:solidFill>
+                  <a:srgbClr val="FFFFFF"/>
+                </a:solidFill>
+                <a:latin typeface="Calibri" pitchFamily="34" charset="0"/>
+                <a:ea typeface="Calibri" pitchFamily="34" charset="-122"/>
+                <a:cs typeface="Calibri" pitchFamily="34" charset="-120"/>
+              </a:rPr>
+              <a:t>We put an intent-validation safety gate between what the voice agent hears and what the agent is allowed to do.</a:t>
+            </a:r>
+            <a:endParaRPr lang="en-US" sz="1600" dirty="0"/>
+          </a:p>
+        </p:txBody>
+      </p:sp>
+      <p:sp>
+        <p:nvSpPr>
+          <p:cNvPr id="11" name="Text 9"/>
+          <p:cNvSpPr txBox="1"/>
+          <p:nvPr/>
+        </p:nvSpPr>
+        <p:spPr>
+          <a:xfrm>
             <a:off x="731520" y="5852160"/>
             <a:ext cx="10515600" cy="365760"/>
           </a:xfrm>
@@ -6094,7 +6133,7 @@
                 <a:ea typeface="Calibri" pitchFamily="34" charset="-122"/>
                 <a:cs typeface="Calibri" pitchFamily="34" charset="-120"/>
               </a:rPr>
-              <a:t>Language check</a:t>
+              <a:t>Claude check</a:t>
             </a:r>
             <a:endParaRPr lang="en-US" sz="1200" dirty="0"/>
           </a:p>
@@ -15680,7 +15719,7 @@
                 <a:ea typeface="Calibri" pitchFamily="34" charset="-122"/>
                 <a:cs typeface="Calibri" pitchFamily="34" charset="-120"/>
               </a:rPr>
-              <a:t>Receives transcript + proposed action → checks intent, negation, risk, SOP and confidence.</a:t>
+              <a:t>Receives transcript + proposed action → Claude checks intent and negation; the gate checks risk, SOP and confidence.</a:t>
             </a:r>
             <a:endParaRPr lang="en-US" sz="1300" dirty="0"/>
           </a:p>
@@ -17516,7 +17555,7 @@
               <a:buNone/>
             </a:pPr>
             <a:r>
-              <a:rPr lang="en-US" sz="1350" i="1" dirty="0">
+              <a:rPr lang="en-US" sz="1300" i="1" dirty="0">
                 <a:solidFill>
                   <a:srgbClr val="5B6475"/>
                 </a:solidFill>
@@ -17524,9 +17563,9 @@
                 <a:ea typeface="Calibri" pitchFamily="34" charset="-122"/>
                 <a:cs typeface="Calibri" pitchFamily="34" charset="-120"/>
               </a:rPr>
-              <a:t>A plug-in layer that makes tool-using AI agents safer for code-mixed Indian conversations</a:t>
-            </a:r>
-            <a:endParaRPr lang="en-US" sz="1350" dirty="0"/>
+              <a:t>Initiative: Codemix Skill  ·  Owner: Team Ramanathan &amp; Sadhana  ·  a plug-in that makes tool-using AI agents safe</a:t>
+            </a:r>
+            <a:endParaRPr lang="en-US" sz="1300" dirty="0"/>
           </a:p>
         </p:txBody>
       </p:sp>
@@ -25650,7 +25689,7 @@
                 <a:ea typeface="Calibri" pitchFamily="34" charset="-122"/>
                 <a:cs typeface="Calibri" pitchFamily="34" charset="-120"/>
               </a:rPr>
-              <a:t>Codemix Skill sits between the agent and its tools: Understand → Decide → Act → Audit.</a:t>
+              <a:t>An intent-validation safety gate between what the voice agent hears and what it is allowed to do: Understand → Decide → Act → Audit.</a:t>
             </a:r>
             <a:endParaRPr lang="en-US" sz="1300" dirty="0"/>
           </a:p>
@@ -29471,17 +29510,17 @@
         <p:spPr>
           <a:xfrm>
             <a:off x="548640" y="1645920"/>
-            <a:ext cx="1920240" cy="1051560"/>
+            <a:ext cx="1783080" cy="960120"/>
           </a:xfrm>
           <a:prstGeom prst="roundRect">
             <a:avLst>
-              <a:gd name="adj" fmla="val 6957"/>
+              <a:gd name="adj" fmla="val 7619"/>
             </a:avLst>
           </a:prstGeom>
           <a:solidFill>
             <a:srgbClr val="E9EDF3"/>
           </a:solidFill>
-          <a:ln w="25400">
+          <a:ln w="12700">
             <a:solidFill>
               <a:srgbClr val="E9EDF3"/>
             </a:solidFill>
@@ -29520,7 +29559,7 @@
                 <a:ea typeface="Calibri" pitchFamily="34" charset="-122"/>
                 <a:cs typeface="Calibri" pitchFamily="34" charset="-120"/>
               </a:rPr>
-              <a:t>voice call</a:t>
+              <a:t>speaks</a:t>
             </a:r>
             <a:endParaRPr lang="en-US" sz="1400" dirty="0"/>
           </a:p>
@@ -29534,8 +29573,8 @@
         </p:nvSpPr>
         <p:spPr>
           <a:xfrm>
-            <a:off x="2468880" y="2171700"/>
-            <a:ext cx="365760" cy="914"/>
+            <a:off x="2331720" y="2125980"/>
+            <a:ext cx="320040" cy="914"/>
           </a:xfrm>
           <a:prstGeom prst="line">
             <a:avLst/>
@@ -29558,18 +29597,18 @@
         </p:nvSpPr>
         <p:spPr>
           <a:xfrm>
-            <a:off x="2834640" y="1645920"/>
-            <a:ext cx="1920240" cy="1051560"/>
+            <a:off x="2651760" y="1645920"/>
+            <a:ext cx="1783080" cy="960120"/>
           </a:xfrm>
           <a:prstGeom prst="roundRect">
             <a:avLst>
-              <a:gd name="adj" fmla="val 6957"/>
+              <a:gd name="adj" fmla="val 7619"/>
             </a:avLst>
           </a:prstGeom>
           <a:solidFill>
             <a:srgbClr val="E4EDF6"/>
           </a:solidFill>
-          <a:ln w="25400">
+          <a:ln w="12700">
             <a:solidFill>
               <a:srgbClr val="E4EDF6"/>
             </a:solidFill>
@@ -29608,7 +29647,7 @@
                 <a:ea typeface="Calibri" pitchFamily="34" charset="-122"/>
                 <a:cs typeface="Calibri" pitchFamily="34" charset="-120"/>
               </a:rPr>
-              <a:t>phone + DTMF</a:t>
+              <a:t>receives the call</a:t>
             </a:r>
             <a:endParaRPr lang="en-US" sz="1400" dirty="0"/>
           </a:p>
@@ -29622,8 +29661,8 @@
         </p:nvSpPr>
         <p:spPr>
           <a:xfrm>
-            <a:off x="4754880" y="2171700"/>
-            <a:ext cx="365760" cy="914"/>
+            <a:off x="4434840" y="2125980"/>
+            <a:ext cx="320040" cy="914"/>
           </a:xfrm>
           <a:prstGeom prst="line">
             <a:avLst/>
@@ -29646,18 +29685,18 @@
         </p:nvSpPr>
         <p:spPr>
           <a:xfrm>
-            <a:off x="5120640" y="1645920"/>
-            <a:ext cx="1920240" cy="1051560"/>
+            <a:off x="4754880" y="1645920"/>
+            <a:ext cx="1783080" cy="960120"/>
           </a:xfrm>
           <a:prstGeom prst="roundRect">
             <a:avLst>
-              <a:gd name="adj" fmla="val 6957"/>
+              <a:gd name="adj" fmla="val 7619"/>
             </a:avLst>
           </a:prstGeom>
           <a:solidFill>
             <a:srgbClr val="E4EDF6"/>
           </a:solidFill>
-          <a:ln w="25400">
+          <a:ln w="12700">
             <a:solidFill>
               <a:srgbClr val="E4EDF6"/>
             </a:solidFill>
@@ -29710,8 +29749,8 @@
         </p:nvSpPr>
         <p:spPr>
           <a:xfrm>
-            <a:off x="7040880" y="2171700"/>
-            <a:ext cx="365760" cy="914"/>
+            <a:off x="6537960" y="2125980"/>
+            <a:ext cx="320040" cy="914"/>
           </a:xfrm>
           <a:prstGeom prst="line">
             <a:avLst/>
@@ -29734,20 +29773,20 @@
         </p:nvSpPr>
         <p:spPr>
           <a:xfrm>
-            <a:off x="7406640" y="1645920"/>
-            <a:ext cx="1920240" cy="1051560"/>
+            <a:off x="6858000" y="1645920"/>
+            <a:ext cx="1783080" cy="960120"/>
           </a:xfrm>
           <a:prstGeom prst="roundRect">
             <a:avLst>
-              <a:gd name="adj" fmla="val 6957"/>
+              <a:gd name="adj" fmla="val 7619"/>
             </a:avLst>
           </a:prstGeom>
           <a:solidFill>
             <a:srgbClr val="14213D"/>
           </a:solidFill>
-          <a:ln w="25400">
-            <a:solidFill>
-              <a:srgbClr val="F4A300"/>
+          <a:ln w="12700">
+            <a:solidFill>
+              <a:srgbClr val="14213D"/>
             </a:solidFill>
           </a:ln>
         </p:spPr>
@@ -29767,7 +29806,7 @@
                 <a:ea typeface="Calibri" pitchFamily="34" charset="-122"/>
                 <a:cs typeface="Calibri" pitchFamily="34" charset="-120"/>
               </a:rPr>
-              <a:t>Codemix Skill</a:t>
+              <a:t>Claude API</a:t>
             </a:r>
             <a:endParaRPr lang="en-US" sz="1400" dirty="0"/>
           </a:p>
@@ -29784,7 +29823,7 @@
                 <a:ea typeface="Calibri" pitchFamily="34" charset="-122"/>
                 <a:cs typeface="Calibri" pitchFamily="34" charset="-120"/>
               </a:rPr>
-              <a:t>intent + negation + decision</a:t>
+              <a:t>intent + negation check</a:t>
             </a:r>
             <a:endParaRPr lang="en-US" sz="1400" dirty="0"/>
           </a:p>
@@ -29798,8 +29837,8 @@
         </p:nvSpPr>
         <p:spPr>
           <a:xfrm>
-            <a:off x="9326880" y="2171700"/>
-            <a:ext cx="365760" cy="914"/>
+            <a:off x="8641080" y="2125980"/>
+            <a:ext cx="320040" cy="914"/>
           </a:xfrm>
           <a:prstGeom prst="line">
             <a:avLst/>
@@ -29822,20 +29861,123 @@
         </p:nvSpPr>
         <p:spPr>
           <a:xfrm>
-            <a:off x="9692640" y="1645920"/>
-            <a:ext cx="1920240" cy="1051560"/>
+            <a:off x="8961120" y="1417320"/>
+            <a:ext cx="2697480" cy="1417320"/>
+          </a:xfrm>
+          <a:prstGeom prst="diamond">
+            <a:avLst/>
+          </a:prstGeom>
+          <a:solidFill>
+            <a:srgbClr val="F4A300"/>
+          </a:solidFill>
+          <a:ln>
+            <a:solidFill>
+              <a:srgbClr val="F4A300"/>
+            </a:solidFill>
+          </a:ln>
+        </p:spPr>
+        <p:txBody>
+          <a:bodyPr wrap="square" lIns="25400" tIns="25400" rIns="25400" bIns="25400" rtlCol="0" anchor="ctr"/>
+          <a:lstStyle/>
+          <a:p>
+            <a:pPr algn="ctr" indent="0" marL="0">
+              <a:buNone/>
+            </a:pPr>
+            <a:r>
+              <a:rPr lang="en-US" sz="1150" b="1" dirty="0">
+                <a:solidFill>
+                  <a:srgbClr val="14213D"/>
+                </a:solidFill>
+                <a:latin typeface="Calibri" pitchFamily="34" charset="0"/>
+                <a:ea typeface="Calibri" pitchFamily="34" charset="-122"/>
+                <a:cs typeface="Calibri" pitchFamily="34" charset="-120"/>
+              </a:rPr>
+              <a:t>SAFETY GATE</a:t>
+            </a:r>
+            <a:endParaRPr lang="en-US" sz="1150" dirty="0"/>
+          </a:p>
+          <a:p>
+            <a:pPr algn="ctr" indent="0" marL="0">
+              <a:buNone/>
+            </a:pPr>
+            <a:r>
+              <a:rPr lang="en-US" sz="1150" b="1" dirty="0">
+                <a:solidFill>
+                  <a:srgbClr val="14213D"/>
+                </a:solidFill>
+                <a:latin typeface="Calibri" pitchFamily="34" charset="0"/>
+                <a:ea typeface="Calibri" pitchFamily="34" charset="-122"/>
+                <a:cs typeface="Calibri" pitchFamily="34" charset="-120"/>
+              </a:rPr>
+              <a:t>Codemix Skill</a:t>
+            </a:r>
+            <a:endParaRPr lang="en-US" sz="1150" dirty="0"/>
+          </a:p>
+          <a:p>
+            <a:pPr algn="ctr" indent="0" marL="0">
+              <a:buNone/>
+            </a:pPr>
+            <a:r>
+              <a:rPr lang="en-US" sz="1150" b="1" dirty="0">
+                <a:solidFill>
+                  <a:srgbClr val="14213D"/>
+                </a:solidFill>
+                <a:latin typeface="Calibri" pitchFamily="34" charset="0"/>
+                <a:ea typeface="Calibri" pitchFamily="34" charset="-122"/>
+                <a:cs typeface="Calibri" pitchFamily="34" charset="-120"/>
+              </a:rPr>
+              <a:t>safe to act?</a:t>
+            </a:r>
+            <a:endParaRPr lang="en-US" sz="1150" dirty="0"/>
+          </a:p>
+        </p:txBody>
+      </p:sp>
+      <p:sp>
+        <p:nvSpPr>
+          <p:cNvPr id="15" name="Shape 13"/>
+          <p:cNvSpPr/>
+          <p:nvPr/>
+        </p:nvSpPr>
+        <p:spPr>
+          <a:xfrm flipH="1">
+            <a:off x="9738360" y="2834640"/>
+            <a:ext cx="571500" cy="594360"/>
+          </a:xfrm>
+          <a:prstGeom prst="line">
+            <a:avLst/>
+          </a:prstGeom>
+          <a:noFill/>
+          <a:ln w="25400">
+            <a:solidFill>
+              <a:srgbClr val="1F8A63"/>
+            </a:solidFill>
+            <a:prstDash val="solid"/>
+            <a:tailEnd type="triangle"/>
+          </a:ln>
+        </p:spPr>
+      </p:sp>
+      <p:sp>
+        <p:nvSpPr>
+          <p:cNvPr id="16" name="Text 14"/>
+          <p:cNvSpPr txBox="1"/>
+          <p:nvPr/>
+        </p:nvSpPr>
+        <p:spPr>
+          <a:xfrm>
+            <a:off x="8275320" y="3429000"/>
+            <a:ext cx="2926080" cy="914400"/>
           </a:xfrm>
           <a:prstGeom prst="roundRect">
             <a:avLst>
-              <a:gd name="adj" fmla="val 6957"/>
+              <a:gd name="adj" fmla="val 8000"/>
             </a:avLst>
           </a:prstGeom>
           <a:solidFill>
             <a:srgbClr val="E1F3EC"/>
           </a:solidFill>
-          <a:ln w="25400">
-            <a:solidFill>
-              <a:srgbClr val="E1F3EC"/>
+          <a:ln w="12700">
+            <a:solidFill>
+              <a:srgbClr val="1F8A63"/>
             </a:solidFill>
           </a:ln>
         </p:spPr>
@@ -29855,7 +29997,7 @@
                 <a:ea typeface="Calibri" pitchFamily="34" charset="-122"/>
                 <a:cs typeface="Calibri" pitchFamily="34" charset="-120"/>
               </a:rPr>
-              <a:t>Company APIs</a:t>
+              <a:t>Dodo Payments</a:t>
             </a:r>
             <a:endParaRPr lang="en-US" sz="1400" dirty="0"/>
           </a:p>
@@ -29872,7 +30014,7 @@
                 <a:ea typeface="Calibri" pitchFamily="34" charset="-122"/>
                 <a:cs typeface="Calibri" pitchFamily="34" charset="-120"/>
               </a:rPr>
-              <a:t>refund / return / replace</a:t>
+              <a:t>refund / return / replacement runs</a:t>
             </a:r>
             <a:endParaRPr lang="en-US" sz="1400" dirty="0"/>
           </a:p>
@@ -29880,22 +30022,61 @@
       </p:sp>
       <p:sp>
         <p:nvSpPr>
-          <p:cNvPr id="15" name="Shape 13"/>
+          <p:cNvPr id="17" name="Text 15"/>
+          <p:cNvSpPr txBox="1"/>
+          <p:nvPr/>
+        </p:nvSpPr>
+        <p:spPr>
+          <a:xfrm>
+            <a:off x="9921240" y="3108960"/>
+            <a:ext cx="1188720" cy="256032"/>
+          </a:xfrm>
+          <a:prstGeom prst="rect">
+            <a:avLst/>
+          </a:prstGeom>
+          <a:noFill/>
+          <a:ln/>
+        </p:spPr>
+        <p:txBody>
+          <a:bodyPr wrap="square" lIns="0" tIns="0" rIns="0" bIns="0" rtlCol="0" anchor="t"/>
+          <a:lstStyle/>
+          <a:p>
+            <a:pPr algn="ctr" indent="0" marL="0">
+              <a:buNone/>
+            </a:pPr>
+            <a:r>
+              <a:rPr lang="en-US" sz="1050" b="1" dirty="0">
+                <a:solidFill>
+                  <a:srgbClr val="1F8A63"/>
+                </a:solidFill>
+                <a:latin typeface="Calibri" pitchFamily="34" charset="0"/>
+                <a:ea typeface="Calibri" pitchFamily="34" charset="-122"/>
+                <a:cs typeface="Calibri" pitchFamily="34" charset="-120"/>
+              </a:rPr>
+              <a:t>YES</a:t>
+            </a:r>
+            <a:endParaRPr lang="en-US" sz="1050" dirty="0"/>
+          </a:p>
+        </p:txBody>
+      </p:sp>
+      <p:sp>
+        <p:nvSpPr>
+          <p:cNvPr id="18" name="Shape 16"/>
           <p:cNvSpPr/>
           <p:nvPr/>
         </p:nvSpPr>
         <p:spPr>
           <a:xfrm>
-            <a:off x="7452360" y="2697480"/>
-            <a:ext cx="914" cy="457200"/>
+            <a:off x="9738360" y="4343400"/>
+            <a:ext cx="914" cy="320040"/>
           </a:xfrm>
           <a:prstGeom prst="line">
             <a:avLst/>
           </a:prstGeom>
           <a:noFill/>
-          <a:ln w="31750">
-            <a:solidFill>
-              <a:srgbClr val="F4A300"/>
+          <a:ln w="19050">
+            <a:solidFill>
+              <a:srgbClr val="5B6475"/>
             </a:solidFill>
             <a:prstDash val="solid"/>
             <a:tailEnd type="triangle"/>
@@ -29904,105 +30085,50 @@
       </p:sp>
       <p:sp>
         <p:nvSpPr>
-          <p:cNvPr id="16" name="Text 14"/>
-          <p:cNvSpPr txBox="1"/>
-          <p:nvPr/>
-        </p:nvSpPr>
-        <p:spPr>
-          <a:xfrm>
-            <a:off x="5989320" y="3154680"/>
-            <a:ext cx="2926080" cy="1234440"/>
-          </a:xfrm>
-          <a:prstGeom prst="diamond">
-            <a:avLst/>
-          </a:prstGeom>
-          <a:solidFill>
-            <a:srgbClr val="F4A300"/>
-          </a:solidFill>
-          <a:ln>
+          <p:cNvPr id="19" name="Shape 17"/>
+          <p:cNvSpPr/>
+          <p:nvPr/>
+        </p:nvSpPr>
+        <p:spPr>
+          <a:xfrm flipH="1">
+            <a:off x="6537960" y="2834640"/>
+            <a:ext cx="3771900" cy="594360"/>
+          </a:xfrm>
+          <a:prstGeom prst="line">
+            <a:avLst/>
+          </a:prstGeom>
+          <a:noFill/>
+          <a:ln w="25400">
             <a:solidFill>
               <a:srgbClr val="F4A300"/>
             </a:solidFill>
-          </a:ln>
-        </p:spPr>
-        <p:txBody>
-          <a:bodyPr wrap="square" lIns="25400" tIns="25400" rIns="25400" bIns="25400" rtlCol="0" anchor="ctr"/>
-          <a:lstStyle/>
-          <a:p>
-            <a:pPr algn="ctr" indent="0" marL="0">
-              <a:buNone/>
-            </a:pPr>
-            <a:r>
-              <a:rPr lang="en-US" sz="1100" b="1" dirty="0">
-                <a:solidFill>
-                  <a:srgbClr val="14213D"/>
-                </a:solidFill>
-                <a:latin typeface="Calibri" pitchFamily="34" charset="0"/>
-                <a:ea typeface="Calibri" pitchFamily="34" charset="-122"/>
-                <a:cs typeface="Calibri" pitchFamily="34" charset="-120"/>
-              </a:rPr>
-              <a:t>Decision layer</a:t>
-            </a:r>
-            <a:endParaRPr lang="en-US" sz="1100" dirty="0"/>
-          </a:p>
-          <a:p>
-            <a:pPr algn="ctr" indent="0" marL="0">
-              <a:buNone/>
-            </a:pPr>
-            <a:r>
-              <a:rPr lang="en-US" sz="1100" b="1" dirty="0">
-                <a:solidFill>
-                  <a:srgbClr val="14213D"/>
-                </a:solidFill>
-                <a:latin typeface="Calibri" pitchFamily="34" charset="0"/>
-                <a:ea typeface="Calibri" pitchFamily="34" charset="-122"/>
-                <a:cs typeface="Calibri" pitchFamily="34" charset="-120"/>
-              </a:rPr>
-              <a:t>ALLOW • CONFIRM</a:t>
-            </a:r>
-            <a:endParaRPr lang="en-US" sz="1100" dirty="0"/>
-          </a:p>
-          <a:p>
-            <a:pPr algn="ctr" indent="0" marL="0">
-              <a:buNone/>
-            </a:pPr>
-            <a:r>
-              <a:rPr lang="en-US" sz="1100" b="1" dirty="0">
-                <a:solidFill>
-                  <a:srgbClr val="14213D"/>
-                </a:solidFill>
-                <a:latin typeface="Calibri" pitchFamily="34" charset="0"/>
-                <a:ea typeface="Calibri" pitchFamily="34" charset="-122"/>
-                <a:cs typeface="Calibri" pitchFamily="34" charset="-120"/>
-              </a:rPr>
-              <a:t>• BLOCK</a:t>
-            </a:r>
-            <a:endParaRPr lang="en-US" sz="1100" dirty="0"/>
-          </a:p>
-        </p:txBody>
-      </p:sp>
-      <p:sp>
-        <p:nvSpPr>
-          <p:cNvPr id="17" name="Text 15"/>
-          <p:cNvSpPr txBox="1"/>
-          <p:nvPr/>
-        </p:nvSpPr>
-        <p:spPr>
-          <a:xfrm>
-            <a:off x="548640" y="4800600"/>
-            <a:ext cx="3017520" cy="1280160"/>
+            <a:prstDash val="solid"/>
+            <a:tailEnd type="triangle"/>
+          </a:ln>
+        </p:spPr>
+      </p:sp>
+      <p:sp>
+        <p:nvSpPr>
+          <p:cNvPr id="20" name="Text 18"/>
+          <p:cNvSpPr txBox="1"/>
+          <p:nvPr/>
+        </p:nvSpPr>
+        <p:spPr>
+          <a:xfrm>
+            <a:off x="5074920" y="3429000"/>
+            <a:ext cx="2926080" cy="914400"/>
           </a:xfrm>
           <a:prstGeom prst="roundRect">
             <a:avLst>
-              <a:gd name="adj" fmla="val 5714"/>
+              <a:gd name="adj" fmla="val 8000"/>
             </a:avLst>
           </a:prstGeom>
           <a:solidFill>
-            <a:srgbClr val="E1F3EC"/>
+            <a:srgbClr val="FFF4DA"/>
           </a:solidFill>
           <a:ln w="12700">
             <a:solidFill>
-              <a:srgbClr val="1F8A63"/>
+              <a:srgbClr val="F4A300"/>
             </a:solidFill>
           </a:ln>
         </p:spPr>
@@ -30016,13 +30142,13 @@
             <a:r>
               <a:rPr lang="en-US" sz="1400" b="1" dirty="0">
                 <a:solidFill>
-                  <a:srgbClr val="1F8A63"/>
-                </a:solidFill>
-                <a:latin typeface="Calibri" pitchFamily="34" charset="0"/>
-                <a:ea typeface="Calibri" pitchFamily="34" charset="-122"/>
-                <a:cs typeface="Calibri" pitchFamily="34" charset="-120"/>
-              </a:rPr>
-              <a:t>ALLOW</a:t>
+                  <a:srgbClr val="7A5000"/>
+                </a:solidFill>
+                <a:latin typeface="Calibri" pitchFamily="34" charset="0"/>
+                <a:ea typeface="Calibri" pitchFamily="34" charset="-122"/>
+                <a:cs typeface="Calibri" pitchFamily="34" charset="-120"/>
+              </a:rPr>
+              <a:t>Confirm with caller</a:t>
             </a:r>
             <a:endParaRPr lang="en-US" sz="1400" dirty="0"/>
           </a:p>
@@ -30031,7 +30157,7 @@
               <a:buNone/>
             </a:pPr>
             <a:r>
-              <a:rPr lang="en-US" sz="1200" dirty="0">
+              <a:rPr lang="en-US" sz="1150" dirty="0">
                 <a:solidFill>
                   <a:srgbClr val="1F2937"/>
                 </a:solidFill>
@@ -30039,7 +30165,7 @@
                 <a:ea typeface="Calibri" pitchFamily="34" charset="-122"/>
                 <a:cs typeface="Calibri" pitchFamily="34" charset="-120"/>
               </a:rPr>
-              <a:t>Safe action → existing API executes + audit.</a:t>
+              <a:t>transparent read-back, voice or DTMF</a:t>
             </a:r>
             <a:endParaRPr lang="en-US" sz="1400" dirty="0"/>
           </a:p>
@@ -30047,22 +30173,61 @@
       </p:sp>
       <p:sp>
         <p:nvSpPr>
-          <p:cNvPr id="18" name="Shape 16"/>
+          <p:cNvPr id="21" name="Text 19"/>
+          <p:cNvSpPr txBox="1"/>
+          <p:nvPr/>
+        </p:nvSpPr>
+        <p:spPr>
+          <a:xfrm>
+            <a:off x="6537960" y="3108960"/>
+            <a:ext cx="1188720" cy="256032"/>
+          </a:xfrm>
+          <a:prstGeom prst="rect">
+            <a:avLst/>
+          </a:prstGeom>
+          <a:noFill/>
+          <a:ln/>
+        </p:spPr>
+        <p:txBody>
+          <a:bodyPr wrap="square" lIns="0" tIns="0" rIns="0" bIns="0" rtlCol="0" anchor="t"/>
+          <a:lstStyle/>
+          <a:p>
+            <a:pPr algn="ctr" indent="0" marL="0">
+              <a:buNone/>
+            </a:pPr>
+            <a:r>
+              <a:rPr lang="en-US" sz="1050" b="1" dirty="0">
+                <a:solidFill>
+                  <a:srgbClr val="7A5000"/>
+                </a:solidFill>
+                <a:latin typeface="Calibri" pitchFamily="34" charset="0"/>
+                <a:ea typeface="Calibri" pitchFamily="34" charset="-122"/>
+                <a:cs typeface="Calibri" pitchFamily="34" charset="-120"/>
+              </a:rPr>
+              <a:t>UNCLEAR</a:t>
+            </a:r>
+            <a:endParaRPr lang="en-US" sz="1050" dirty="0"/>
+          </a:p>
+        </p:txBody>
+      </p:sp>
+      <p:sp>
+        <p:nvSpPr>
+          <p:cNvPr id="22" name="Shape 20"/>
           <p:cNvSpPr/>
           <p:nvPr/>
         </p:nvSpPr>
         <p:spPr>
-          <a:xfrm flipH="1">
-            <a:off x="2057400" y="4389120"/>
-            <a:ext cx="5394960" cy="411480"/>
+          <a:xfrm>
+            <a:off x="6537960" y="4343400"/>
+            <a:ext cx="914" cy="320040"/>
           </a:xfrm>
           <a:prstGeom prst="line">
             <a:avLst/>
           </a:prstGeom>
           <a:noFill/>
-          <a:ln w="25400">
-            <a:solidFill>
-              <a:srgbClr val="1F8A63"/>
+          <a:ln w="19050">
+            <a:solidFill>
+              <a:srgbClr val="5B6475"/>
             </a:solidFill>
             <a:prstDash val="solid"/>
             <a:tailEnd type="triangle"/>
@@ -30071,26 +30236,50 @@
       </p:sp>
       <p:sp>
         <p:nvSpPr>
-          <p:cNvPr id="19" name="Text 17"/>
-          <p:cNvSpPr txBox="1"/>
-          <p:nvPr/>
-        </p:nvSpPr>
-        <p:spPr>
-          <a:xfrm>
-            <a:off x="4251960" y="4800600"/>
-            <a:ext cx="3017520" cy="1280160"/>
+          <p:cNvPr id="23" name="Shape 21"/>
+          <p:cNvSpPr/>
+          <p:nvPr/>
+        </p:nvSpPr>
+        <p:spPr>
+          <a:xfrm flipH="1">
+            <a:off x="3337560" y="2834640"/>
+            <a:ext cx="6972300" cy="594360"/>
+          </a:xfrm>
+          <a:prstGeom prst="line">
+            <a:avLst/>
+          </a:prstGeom>
+          <a:noFill/>
+          <a:ln w="25400">
+            <a:solidFill>
+              <a:srgbClr val="C8283C"/>
+            </a:solidFill>
+            <a:prstDash val="solid"/>
+            <a:tailEnd type="triangle"/>
+          </a:ln>
+        </p:spPr>
+      </p:sp>
+      <p:sp>
+        <p:nvSpPr>
+          <p:cNvPr id="24" name="Text 22"/>
+          <p:cNvSpPr txBox="1"/>
+          <p:nvPr/>
+        </p:nvSpPr>
+        <p:spPr>
+          <a:xfrm>
+            <a:off x="1874520" y="3429000"/>
+            <a:ext cx="2926080" cy="914400"/>
           </a:xfrm>
           <a:prstGeom prst="roundRect">
             <a:avLst>
-              <a:gd name="adj" fmla="val 5714"/>
+              <a:gd name="adj" fmla="val 8000"/>
             </a:avLst>
           </a:prstGeom>
           <a:solidFill>
-            <a:srgbClr val="FFF4DA"/>
+            <a:srgbClr val="FBE4E7"/>
           </a:solidFill>
           <a:ln w="12700">
             <a:solidFill>
-              <a:srgbClr val="F4A300"/>
+              <a:srgbClr val="C8283C"/>
             </a:solidFill>
           </a:ln>
         </p:spPr>
@@ -30104,13 +30293,13 @@
             <a:r>
               <a:rPr lang="en-US" sz="1400" b="1" dirty="0">
                 <a:solidFill>
-                  <a:srgbClr val="7A5000"/>
-                </a:solidFill>
-                <a:latin typeface="Calibri" pitchFamily="34" charset="0"/>
-                <a:ea typeface="Calibri" pitchFamily="34" charset="-122"/>
-                <a:cs typeface="Calibri" pitchFamily="34" charset="-120"/>
-              </a:rPr>
-              <a:t>CONFIRM</a:t>
+                  <a:srgbClr val="C8283C"/>
+                </a:solidFill>
+                <a:latin typeface="Calibri" pitchFamily="34" charset="0"/>
+                <a:ea typeface="Calibri" pitchFamily="34" charset="-122"/>
+                <a:cs typeface="Calibri" pitchFamily="34" charset="-120"/>
+              </a:rPr>
+              <a:t>Freshworks ticket</a:t>
             </a:r>
             <a:endParaRPr lang="en-US" sz="1400" dirty="0"/>
           </a:p>
@@ -30119,7 +30308,7 @@
               <a:buNone/>
             </a:pPr>
             <a:r>
-              <a:rPr lang="en-US" sz="1200" dirty="0">
+              <a:rPr lang="en-US" sz="1150" dirty="0">
                 <a:solidFill>
                   <a:srgbClr val="1F2937"/>
                 </a:solidFill>
@@ -30127,7 +30316,7 @@
                 <a:ea typeface="Calibri" pitchFamily="34" charset="-122"/>
                 <a:cs typeface="Calibri" pitchFamily="34" charset="-120"/>
               </a:rPr>
-              <a:t>Uncertain / irreversible → transparent read-back + voice or DTMF.</a:t>
+              <a:t>Freshdesk case for a human agent</a:t>
             </a:r>
             <a:endParaRPr lang="en-US" sz="1400" dirty="0"/>
           </a:p>
@@ -30135,22 +30324,61 @@
       </p:sp>
       <p:sp>
         <p:nvSpPr>
-          <p:cNvPr id="20" name="Shape 18"/>
+          <p:cNvPr id="25" name="Text 23"/>
+          <p:cNvSpPr txBox="1"/>
+          <p:nvPr/>
+        </p:nvSpPr>
+        <p:spPr>
+          <a:xfrm>
+            <a:off x="3337560" y="3108960"/>
+            <a:ext cx="1188720" cy="256032"/>
+          </a:xfrm>
+          <a:prstGeom prst="rect">
+            <a:avLst/>
+          </a:prstGeom>
+          <a:noFill/>
+          <a:ln/>
+        </p:spPr>
+        <p:txBody>
+          <a:bodyPr wrap="square" lIns="0" tIns="0" rIns="0" bIns="0" rtlCol="0" anchor="t"/>
+          <a:lstStyle/>
+          <a:p>
+            <a:pPr algn="ctr" indent="0" marL="0">
+              <a:buNone/>
+            </a:pPr>
+            <a:r>
+              <a:rPr lang="en-US" sz="1050" b="1" dirty="0">
+                <a:solidFill>
+                  <a:srgbClr val="C8283C"/>
+                </a:solidFill>
+                <a:latin typeface="Calibri" pitchFamily="34" charset="0"/>
+                <a:ea typeface="Calibri" pitchFamily="34" charset="-122"/>
+                <a:cs typeface="Calibri" pitchFamily="34" charset="-120"/>
+              </a:rPr>
+              <a:t>NO / angry</a:t>
+            </a:r>
+            <a:endParaRPr lang="en-US" sz="1050" dirty="0"/>
+          </a:p>
+        </p:txBody>
+      </p:sp>
+      <p:sp>
+        <p:nvSpPr>
+          <p:cNvPr id="26" name="Shape 24"/>
           <p:cNvSpPr/>
           <p:nvPr/>
         </p:nvSpPr>
         <p:spPr>
-          <a:xfrm flipH="1">
-            <a:off x="5760720" y="4389120"/>
-            <a:ext cx="1691640" cy="411480"/>
+          <a:xfrm>
+            <a:off x="3337560" y="4343400"/>
+            <a:ext cx="914" cy="320040"/>
           </a:xfrm>
           <a:prstGeom prst="line">
             <a:avLst/>
           </a:prstGeom>
           <a:noFill/>
-          <a:ln w="25400">
-            <a:solidFill>
-              <a:srgbClr val="F4A300"/>
+          <a:ln w="19050">
+            <a:solidFill>
+              <a:srgbClr val="5B6475"/>
             </a:solidFill>
             <a:prstDash val="solid"/>
             <a:tailEnd type="triangle"/>
@@ -30159,26 +30387,26 @@
       </p:sp>
       <p:sp>
         <p:nvSpPr>
-          <p:cNvPr id="21" name="Text 19"/>
-          <p:cNvSpPr txBox="1"/>
-          <p:nvPr/>
-        </p:nvSpPr>
-        <p:spPr>
-          <a:xfrm>
-            <a:off x="7955280" y="4800600"/>
-            <a:ext cx="3017520" cy="1280160"/>
+          <p:cNvPr id="27" name="Text 25"/>
+          <p:cNvSpPr txBox="1"/>
+          <p:nvPr/>
+        </p:nvSpPr>
+        <p:spPr>
+          <a:xfrm>
+            <a:off x="1874520" y="4663440"/>
+            <a:ext cx="9326880" cy="548640"/>
           </a:xfrm>
           <a:prstGeom prst="roundRect">
             <a:avLst>
-              <a:gd name="adj" fmla="val 5714"/>
+              <a:gd name="adj" fmla="val 13333"/>
             </a:avLst>
           </a:prstGeom>
           <a:solidFill>
-            <a:srgbClr val="FBE4E7"/>
+            <a:srgbClr val="E4EDF6"/>
           </a:solidFill>
           <a:ln w="12700">
             <a:solidFill>
-              <a:srgbClr val="C8283C"/>
+              <a:srgbClr val="E4EDF6"/>
             </a:solidFill>
           </a:ln>
         </p:spPr>
@@ -30190,64 +30418,110 @@
               <a:buNone/>
             </a:pPr>
             <a:r>
+              <a:rPr lang="en-US" sz="1300" b="1" dirty="0">
+                <a:solidFill>
+                  <a:srgbClr val="2A5C8A"/>
+                </a:solidFill>
+                <a:latin typeface="Calibri" pitchFamily="34" charset="0"/>
+                <a:ea typeface="Calibri" pitchFamily="34" charset="-122"/>
+                <a:cs typeface="Calibri" pitchFamily="34" charset="-120"/>
+              </a:rPr>
+              <a:t>ElevenLabs speaks the reply in the caller's own language mix</a:t>
+            </a:r>
+            <a:endParaRPr lang="en-US" sz="1300" dirty="0"/>
+          </a:p>
+        </p:txBody>
+      </p:sp>
+      <p:sp>
+        <p:nvSpPr>
+          <p:cNvPr id="28" name="Shape 26"/>
+          <p:cNvSpPr/>
+          <p:nvPr/>
+        </p:nvSpPr>
+        <p:spPr>
+          <a:xfrm>
+            <a:off x="548640" y="5440680"/>
+            <a:ext cx="11109960" cy="731520"/>
+          </a:xfrm>
+          <a:prstGeom prst="roundRect">
+            <a:avLst>
+              <a:gd name="adj" fmla="val 12500"/>
+            </a:avLst>
+          </a:prstGeom>
+          <a:solidFill>
+            <a:srgbClr val="14213D"/>
+          </a:solidFill>
+          <a:ln w="9525">
+            <a:solidFill>
+              <a:srgbClr val="DDE3EB"/>
+            </a:solidFill>
+            <a:prstDash val="solid"/>
+          </a:ln>
+          <a:effectLst>
+            <a:outerShdw sx="100000" sy="100000" kx="0" ky="0" algn="bl" rotWithShape="0" blurRad="76200" dist="25400" dir="5400000">
+              <a:srgbClr val="000000">
+                <a:alpha val="12000"/>
+              </a:srgbClr>
+            </a:outerShdw>
+          </a:effectLst>
+        </p:spPr>
+      </p:sp>
+      <p:sp>
+        <p:nvSpPr>
+          <p:cNvPr id="29" name="Text 27"/>
+          <p:cNvSpPr txBox="1"/>
+          <p:nvPr/>
+        </p:nvSpPr>
+        <p:spPr>
+          <a:xfrm>
+            <a:off x="777240" y="5440680"/>
+            <a:ext cx="10652760" cy="731520"/>
+          </a:xfrm>
+          <a:prstGeom prst="rect">
+            <a:avLst/>
+          </a:prstGeom>
+          <a:noFill/>
+          <a:ln/>
+        </p:spPr>
+        <p:txBody>
+          <a:bodyPr wrap="square" lIns="0" tIns="0" rIns="0" bIns="0" rtlCol="0" anchor="ctr"/>
+          <a:lstStyle/>
+          <a:p>
+            <a:pPr indent="0" marL="0">
+              <a:buNone/>
+            </a:pPr>
+            <a:r>
               <a:rPr lang="en-US" sz="1400" b="1" dirty="0">
                 <a:solidFill>
-                  <a:srgbClr val="C8283C"/>
-                </a:solidFill>
-                <a:latin typeface="Calibri" pitchFamily="34" charset="0"/>
-                <a:ea typeface="Calibri" pitchFamily="34" charset="-122"/>
-                <a:cs typeface="Calibri" pitchFamily="34" charset="-120"/>
-              </a:rPr>
-              <a:t>BLOCK / HANDOFF</a:t>
+                  <a:srgbClr val="F4A300"/>
+                </a:solidFill>
+                <a:latin typeface="Calibri" pitchFamily="34" charset="0"/>
+                <a:ea typeface="Calibri" pitchFamily="34" charset="-122"/>
+                <a:cs typeface="Calibri" pitchFamily="34" charset="-120"/>
+              </a:rPr>
+              <a:t>Our innovation  </a:t>
+            </a:r>
+            <a:pPr indent="0" marL="0">
+              <a:buNone/>
+            </a:pPr>
+            <a:r>
+              <a:rPr lang="en-US" sz="1400" dirty="0">
+                <a:solidFill>
+                  <a:srgbClr val="FFFFFF"/>
+                </a:solidFill>
+                <a:latin typeface="Calibri" pitchFamily="34" charset="0"/>
+                <a:ea typeface="Calibri" pitchFamily="34" charset="-122"/>
+                <a:cs typeface="Calibri" pitchFamily="34" charset="-120"/>
+              </a:rPr>
+              <a:t>We put an intent-validation safety gate between what the voice agent hears and what the agent is allowed to do.</a:t>
             </a:r>
             <a:endParaRPr lang="en-US" sz="1400" dirty="0"/>
           </a:p>
-          <a:p>
-            <a:pPr algn="ctr" indent="0" marL="0">
-              <a:buNone/>
-            </a:pPr>
-            <a:r>
-              <a:rPr lang="en-US" sz="1200" dirty="0">
-                <a:solidFill>
-                  <a:srgbClr val="1F2937"/>
-                </a:solidFill>
-                <a:latin typeface="Calibri" pitchFamily="34" charset="0"/>
-                <a:ea typeface="Calibri" pitchFamily="34" charset="-122"/>
-                <a:cs typeface="Calibri" pitchFamily="34" charset="-120"/>
-              </a:rPr>
-              <a:t>Unsafe, failed confirmation or angry caller → Freshdesk ticket + human.</a:t>
-            </a:r>
-            <a:endParaRPr lang="en-US" sz="1400" dirty="0"/>
-          </a:p>
-        </p:txBody>
-      </p:sp>
-      <p:sp>
-        <p:nvSpPr>
-          <p:cNvPr id="22" name="Shape 20"/>
-          <p:cNvSpPr/>
-          <p:nvPr/>
-        </p:nvSpPr>
-        <p:spPr>
-          <a:xfrm>
-            <a:off x="7452360" y="4389120"/>
-            <a:ext cx="2011680" cy="411480"/>
-          </a:xfrm>
-          <a:prstGeom prst="line">
-            <a:avLst/>
-          </a:prstGeom>
-          <a:noFill/>
-          <a:ln w="25400">
-            <a:solidFill>
-              <a:srgbClr val="C8283C"/>
-            </a:solidFill>
-            <a:prstDash val="solid"/>
-            <a:tailEnd type="triangle"/>
-          </a:ln>
-        </p:spPr>
-      </p:sp>
-      <p:sp>
-        <p:nvSpPr>
-          <p:cNvPr id="23" name="Text 21"/>
+        </p:txBody>
+      </p:sp>
+      <p:sp>
+        <p:nvSpPr>
+          <p:cNvPr id="30" name="Text 28"/>
           <p:cNvSpPr txBox="1"/>
           <p:nvPr/>
         </p:nvSpPr>
@@ -30643,7 +30917,7 @@
                 <a:ea typeface="Calibri" pitchFamily="34" charset="-122"/>
                 <a:cs typeface="Calibri" pitchFamily="34" charset="-120"/>
               </a:rPr>
-              <a:t>Customer-facing phone access, IVR/keypad input and deterministic confirmation.</a:t>
+              <a:t>The number customers call. Keypad (DTMF) gives a confirmation that needs no speech recognition.</a:t>
             </a:r>
             <a:endParaRPr lang="en-US" sz="1150" dirty="0"/>
           </a:p>
@@ -30834,7 +31108,7 @@
                 <a:ea typeface="Calibri" pitchFamily="34" charset="-122"/>
                 <a:cs typeface="Calibri" pitchFamily="34" charset="-120"/>
               </a:rPr>
-              <a:t>Indian-language and code-mixed speech transcription for downstream intent validation.</a:t>
+              <a:t>Transcribes code-mixed Hindi + English and Tamil + English, so the negation reaches the intent check.</a:t>
             </a:r>
             <a:endParaRPr lang="en-US" sz="1150" dirty="0"/>
           </a:p>
@@ -31025,7 +31299,7 @@
                 <a:ea typeface="Calibri" pitchFamily="34" charset="-122"/>
                 <a:cs typeface="Calibri" pitchFamily="34" charset="-120"/>
               </a:rPr>
-              <a:t>Checks actual intent, negation, conflicting meaning and uncertainty before sensitive actions.</a:t>
+              <a:t>Before any sensitive action: finds the real intent. “Refund vendam” = NO refund, YES replacement.</a:t>
             </a:r>
             <a:endParaRPr lang="en-US" sz="1150" dirty="0"/>
           </a:p>
@@ -31216,7 +31490,7 @@
                 <a:ea typeface="Calibri" pitchFamily="34" charset="-122"/>
                 <a:cs typeface="Calibri" pitchFamily="34" charset="-120"/>
               </a:rPr>
-              <a:t>The orchestration + safety layer between the agent and action APIs.</a:t>
+              <a:t>The safety gate between what the voice agent hears and what it is allowed to do.</a:t>
             </a:r>
             <a:endParaRPr lang="en-US" sz="1150" dirty="0"/>
           </a:p>
@@ -31407,7 +31681,7 @@
                 <a:ea typeface="Calibri" pitchFamily="34" charset="-122"/>
                 <a:cs typeface="Calibri" pitchFamily="34" charset="-120"/>
               </a:rPr>
-              <a:t>Demonstration action layer for refund/return/replacement; called only after the decision gate.</a:t>
+              <a:t>Runs refunds, returns and replacements, but only after the safety gate says YES.</a:t>
             </a:r>
             <a:endParaRPr lang="en-US" sz="1150" dirty="0"/>
           </a:p>
@@ -31598,7 +31872,7 @@
                 <a:ea typeface="Calibri" pitchFamily="34" charset="-122"/>
                 <a:cs typeface="Calibri" pitchFamily="34" charset="-120"/>
               </a:rPr>
-              <a:t>Creates structured tickets when the AI should not resolve the case alone.</a:t>
+              <a:t>If it can't be resolved safely, a Freshdesk ticket hands the case to a human agent.</a:t>
             </a:r>
             <a:endParaRPr lang="en-US" sz="1150" dirty="0"/>
           </a:p>
@@ -31789,7 +32063,7 @@
                 <a:ea typeface="Calibri" pitchFamily="34" charset="-122"/>
                 <a:cs typeface="Calibri" pitchFamily="34" charset="-120"/>
               </a:rPr>
-              <a:t>Natural response + transparent read-back / confirmation.</a:t>
+              <a:t>Speaks the reply in the caller's own language mix and reads back what it understood.</a:t>
             </a:r>
             <a:endParaRPr lang="en-US" sz="1150" dirty="0"/>
           </a:p>

</xml_diff>